<commit_message>
Deck: retitle slide 19 as Amina's Case Study, remove tick/cross marks, revert the Word file
- Slide 19 header: 'Case Application' -> "Amina's Case Study"
- Slide 11: removed the tick/cross marks before the language examples; the
  two example lines keep their existing wording, font and accent colour
- No design, layout, colour, font, image, animation or transition changes
- GESTALT THERAPY GROUP WORK.docx restored to its previous state (no edits)
- Gates: render QA 0 issues, 280/280 required phrases, 0 tick glyphs deck-wide

Co-authored-by: arena-agent <297053741+arena-agent@users.noreply.github.com>
</commit_message>
<xml_diff>
--- a/presentations/gestalt-theory-counselling/output/Gestalt Theory and Its Application to Counselling.pptx
+++ b/presentations/gestalt-theory-counselling/output/Gestalt Theory and Its Application to Counselling.pptx
@@ -5224,20 +5224,6 @@
               <a:buNone/>
             </a:pPr>
             <a:r>
-              <a:rPr lang="en-US" sz="1400" b="1" dirty="0">
-                <a:solidFill>
-                  <a:srgbClr val="FFFFFF"/>
-                </a:solidFill>
-                <a:latin typeface="Outfit" pitchFamily="34" charset="0"/>
-                <a:ea typeface="Outfit" pitchFamily="34" charset="-122"/>
-                <a:cs typeface="Outfit" pitchFamily="34" charset="-120"/>
-              </a:rPr>
-              <a:t>✗   </a:t>
-            </a:r>
-            <a:pPr indent="0" marL="0">
-              <a:buNone/>
-            </a:pPr>
-            <a:r>
               <a:rPr lang="en-US" sz="1450" i="1" dirty="0">
                 <a:solidFill>
                   <a:srgbClr val="FFFFFF"/>
@@ -5248,7 +5234,7 @@
               </a:rPr>
               <a:t>“You make me angry.”</a:t>
             </a:r>
-            <a:endParaRPr lang="en-US" sz="1400" dirty="0"/>
+            <a:endParaRPr lang="en-US" sz="1450" dirty="0"/>
           </a:p>
         </p:txBody>
       </p:sp>
@@ -5277,23 +5263,9 @@
               <a:buNone/>
             </a:pPr>
             <a:r>
-              <a:rPr lang="en-US" sz="1400" b="1" dirty="0">
+              <a:rPr lang="en-US" sz="1450" i="1" dirty="0">
                 <a:solidFill>
                   <a:srgbClr val="8097BE"/>
-                </a:solidFill>
-                <a:latin typeface="Outfit" pitchFamily="34" charset="0"/>
-                <a:ea typeface="Outfit" pitchFamily="34" charset="-122"/>
-                <a:cs typeface="Outfit" pitchFamily="34" charset="-120"/>
-              </a:rPr>
-              <a:t>✓   </a:t>
-            </a:r>
-            <a:pPr indent="0" marL="0">
-              <a:buNone/>
-            </a:pPr>
-            <a:r>
-              <a:rPr lang="en-US" sz="1450" i="1" dirty="0">
-                <a:solidFill>
-                  <a:srgbClr val="FFFFFF"/>
                 </a:solidFill>
                 <a:latin typeface="Playfair Display" pitchFamily="34" charset="0"/>
                 <a:ea typeface="Playfair Display" pitchFamily="34" charset="-122"/>
@@ -5301,7 +5273,7 @@
               </a:rPr>
               <a:t>“I notice that I become angry when…”</a:t>
             </a:r>
-            <a:endParaRPr lang="en-US" sz="1400" dirty="0"/>
+            <a:endParaRPr lang="en-US" sz="1450" dirty="0"/>
           </a:p>
         </p:txBody>
       </p:sp>
@@ -14051,7 +14023,7 @@
                 <a:ea typeface="Playfair Display" pitchFamily="34" charset="-122"/>
                 <a:cs typeface="Playfair Display" pitchFamily="34" charset="-120"/>
               </a:rPr>
-              <a:t>Case Application</a:t>
+              <a:t>Amina’s Case Study</a:t>
             </a:r>
             <a:endParaRPr lang="en-US" sz="2600" dirty="0"/>
           </a:p>

</xml_diff>

<commit_message>
Deck conclusion: highlight the issues in the first block only (accent colour on the five issue words)
Co-authored-by: arena-agent <297053741+arena-agent@users.noreply.github.com>
</commit_message>
<xml_diff>
--- a/presentations/gestalt-theory-counselling/output/Gestalt Theory and Its Application to Counselling.pptx
+++ b/presentations/gestalt-theory-counselling/output/Gestalt Theory and Its Application to Counselling.pptx
@@ -16782,7 +16782,7 @@
             <a:r>
               <a:rPr lang="en-US" sz="1300" b="1" spc="150" kern="0" dirty="0">
                 <a:solidFill>
-                  <a:srgbClr val="FFFFFF"/>
+                  <a:srgbClr val="8097BE"/>
                 </a:solidFill>
                 <a:latin typeface="Outfit" pitchFamily="34" charset="0"/>
                 <a:ea typeface="Outfit" pitchFamily="34" charset="-122"/>
@@ -16860,7 +16860,7 @@
             <a:r>
               <a:rPr lang="en-US" sz="1300" b="1" spc="150" kern="0" dirty="0">
                 <a:solidFill>
-                  <a:srgbClr val="FFFFFF"/>
+                  <a:srgbClr val="8097BE"/>
                 </a:solidFill>
                 <a:latin typeface="Outfit" pitchFamily="34" charset="0"/>
                 <a:ea typeface="Outfit" pitchFamily="34" charset="-122"/>
@@ -16938,7 +16938,7 @@
             <a:r>
               <a:rPr lang="en-US" sz="1300" b="1" spc="150" kern="0" dirty="0">
                 <a:solidFill>
-                  <a:srgbClr val="FFFFFF"/>
+                  <a:srgbClr val="8097BE"/>
                 </a:solidFill>
                 <a:latin typeface="Outfit" pitchFamily="34" charset="0"/>
                 <a:ea typeface="Outfit" pitchFamily="34" charset="-122"/>
@@ -17016,7 +17016,7 @@
             <a:r>
               <a:rPr lang="en-US" sz="1300" b="1" spc="150" kern="0" dirty="0">
                 <a:solidFill>
-                  <a:srgbClr val="FFFFFF"/>
+                  <a:srgbClr val="8097BE"/>
                 </a:solidFill>
                 <a:latin typeface="Outfit" pitchFamily="34" charset="0"/>
                 <a:ea typeface="Outfit" pitchFamily="34" charset="-122"/>

</xml_diff>